<commit_message>
add last requiremtns to submit in forms
</commit_message>
<xml_diff>
--- a/2-Studex_Presentation.pptx
+++ b/2-Studex_Presentation.pptx
@@ -3558,13 +3558,13 @@
   <p:clrMapOvr>
     <a:masterClrMapping/>
   </p:clrMapOvr>
-  <mc:AlternateContent xmlns:mc="http://schemas.openxmlformats.org/markup-compatibility/2006">
-    <mc:Choice xmlns:p159="http://schemas.microsoft.com/office/powerpoint/2015/09/main" Requires="p159">
+  <mc:AlternateContent xmlns:mc="http://schemas.openxmlformats.org/markup-compatibility/2006" xmlns:p159="http://schemas.microsoft.com/office/powerpoint/2015/09/main">
+    <mc:Choice Requires="p159">
       <p:transition xmlns:p14="http://schemas.microsoft.com/office/powerpoint/2010/main" spd="slow" p14:dur="2000">
         <p159:morph option="byObject"/>
       </p:transition>
     </mc:Choice>
-    <mc:Fallback>
+    <mc:Fallback xmlns="">
       <p:transition spd="slow">
         <p:fade/>
       </p:transition>
@@ -4579,13 +4579,13 @@
   <p:clrMapOvr>
     <a:masterClrMapping/>
   </p:clrMapOvr>
-  <mc:AlternateContent xmlns:mc="http://schemas.openxmlformats.org/markup-compatibility/2006">
-    <mc:Choice xmlns:p159="http://schemas.microsoft.com/office/powerpoint/2015/09/main" Requires="p159">
+  <mc:AlternateContent xmlns:mc="http://schemas.openxmlformats.org/markup-compatibility/2006" xmlns:p159="http://schemas.microsoft.com/office/powerpoint/2015/09/main">
+    <mc:Choice Requires="p159">
       <p:transition xmlns:p14="http://schemas.microsoft.com/office/powerpoint/2010/main" spd="slow" p14:dur="2000">
         <p159:morph option="byObject"/>
       </p:transition>
     </mc:Choice>
-    <mc:Fallback>
+    <mc:Fallback xmlns="">
       <p:transition spd="slow">
         <p:fade/>
       </p:transition>
@@ -5971,13 +5971,13 @@
   <p:clrMapOvr>
     <a:masterClrMapping/>
   </p:clrMapOvr>
-  <mc:AlternateContent xmlns:mc="http://schemas.openxmlformats.org/markup-compatibility/2006">
-    <mc:Choice xmlns:p159="http://schemas.microsoft.com/office/powerpoint/2015/09/main" Requires="p159">
+  <mc:AlternateContent xmlns:mc="http://schemas.openxmlformats.org/markup-compatibility/2006" xmlns:p159="http://schemas.microsoft.com/office/powerpoint/2015/09/main">
+    <mc:Choice Requires="p159">
       <p:transition xmlns:p14="http://schemas.microsoft.com/office/powerpoint/2010/main" spd="slow" p14:dur="2000">
         <p159:morph option="byObject"/>
       </p:transition>
     </mc:Choice>
-    <mc:Fallback>
+    <mc:Fallback xmlns="">
       <p:transition spd="slow">
         <p:fade/>
       </p:transition>
@@ -6236,7 +6236,7 @@
           <a:bodyPr/>
           <a:lstStyle/>
           <a:p>
-            <a:endParaRPr lang="en-US"/>
+            <a:endParaRPr lang="en-US" dirty="0"/>
           </a:p>
         </p:txBody>
       </p:sp>
@@ -6576,6 +6576,18 @@
   <p:clrMapOvr>
     <a:masterClrMapping/>
   </p:clrMapOvr>
+  <mc:AlternateContent xmlns:mc="http://schemas.openxmlformats.org/markup-compatibility/2006">
+    <mc:Choice xmlns:p159="http://schemas.microsoft.com/office/powerpoint/2015/09/main" Requires="p159">
+      <p:transition xmlns:p14="http://schemas.microsoft.com/office/powerpoint/2010/main" spd="slow" p14:dur="2000">
+        <p159:morph option="byObject"/>
+      </p:transition>
+    </mc:Choice>
+    <mc:Fallback>
+      <p:transition spd="slow">
+        <p:fade/>
+      </p:transition>
+    </mc:Fallback>
+  </mc:AlternateContent>
 </p:sld>
 </file>
 
@@ -6604,6 +6616,36 @@
           <a:chExt cx="0" cy="0"/>
         </a:xfrm>
       </p:grpSpPr>
+      <p:pic>
+        <p:nvPicPr>
+          <p:cNvPr id="10" name="Picture 9">
+            <a:extLst>
+              <a:ext uri="{FF2B5EF4-FFF2-40B4-BE49-F238E27FC236}">
+                <a16:creationId xmlns:a16="http://schemas.microsoft.com/office/drawing/2014/main" id="{6AB042CD-7126-5EF3-A07D-94013EBAC6FA}"/>
+              </a:ext>
+            </a:extLst>
+          </p:cNvPr>
+          <p:cNvPicPr>
+            <a:picLocks noChangeAspect="1"/>
+          </p:cNvPicPr>
+          <p:nvPr/>
+        </p:nvPicPr>
+        <p:blipFill>
+          <a:blip r:embed="rId3"/>
+          <a:stretch>
+            <a:fillRect/>
+          </a:stretch>
+        </p:blipFill>
+        <p:spPr>
+          <a:xfrm>
+            <a:off x="1672390" y="2101681"/>
+            <a:ext cx="5991726" cy="2259527"/>
+          </a:xfrm>
+          <a:prstGeom prst="rect">
+            <a:avLst/>
+          </a:prstGeom>
+        </p:spPr>
+      </p:pic>
       <p:sp>
         <p:nvSpPr>
           <p:cNvPr id="2" name="Shape 0"/>
@@ -6676,7 +6718,7 @@
         </p:nvSpPr>
         <p:spPr>
           <a:xfrm>
-            <a:off x="457200" y="731520"/>
+            <a:off x="-104274" y="-149192"/>
             <a:ext cx="8229600" cy="1828800"/>
           </a:xfrm>
           <a:prstGeom prst="rect">
@@ -6715,7 +6757,7 @@
         </p:nvSpPr>
         <p:spPr>
           <a:xfrm>
-            <a:off x="2743200" y="2743200"/>
+            <a:off x="2181726" y="1626673"/>
             <a:ext cx="3657600" cy="73152"/>
           </a:xfrm>
           <a:prstGeom prst="roundRect">
@@ -6749,7 +6791,7 @@
         </p:nvSpPr>
         <p:spPr>
           <a:xfrm>
-            <a:off x="457200" y="2926080"/>
+            <a:off x="-248652" y="1611028"/>
             <a:ext cx="8229600" cy="594360"/>
           </a:xfrm>
           <a:prstGeom prst="rect">
@@ -6788,7 +6830,7 @@
         </p:nvSpPr>
         <p:spPr>
           <a:xfrm>
-            <a:off x="457200" y="3611880"/>
+            <a:off x="336885" y="4341722"/>
             <a:ext cx="8229600" cy="457200"/>
           </a:xfrm>
           <a:prstGeom prst="rect">
@@ -6827,7 +6869,7 @@
         </p:nvSpPr>
         <p:spPr>
           <a:xfrm>
-            <a:off x="457200" y="4389120"/>
+            <a:off x="336885" y="4644591"/>
             <a:ext cx="8229600" cy="457200"/>
           </a:xfrm>
           <a:prstGeom prst="rect">
@@ -6863,6 +6905,18 @@
   <p:clrMapOvr>
     <a:masterClrMapping/>
   </p:clrMapOvr>
+  <mc:AlternateContent xmlns:mc="http://schemas.openxmlformats.org/markup-compatibility/2006">
+    <mc:Choice xmlns:p159="http://schemas.microsoft.com/office/powerpoint/2015/09/main" Requires="p159">
+      <p:transition xmlns:p14="http://schemas.microsoft.com/office/powerpoint/2010/main" spd="slow" p14:dur="2000">
+        <p159:morph option="byObject"/>
+      </p:transition>
+    </mc:Choice>
+    <mc:Fallback>
+      <p:transition spd="slow">
+        <p:fade/>
+      </p:transition>
+    </mc:Fallback>
+  </mc:AlternateContent>
 </p:sld>
 </file>
 
@@ -7606,13 +7660,13 @@
   <p:clrMapOvr>
     <a:masterClrMapping/>
   </p:clrMapOvr>
-  <mc:AlternateContent xmlns:mc="http://schemas.openxmlformats.org/markup-compatibility/2006">
-    <mc:Choice xmlns:p159="http://schemas.microsoft.com/office/powerpoint/2015/09/main" Requires="p159">
+  <mc:AlternateContent xmlns:mc="http://schemas.openxmlformats.org/markup-compatibility/2006" xmlns:p159="http://schemas.microsoft.com/office/powerpoint/2015/09/main">
+    <mc:Choice Requires="p159">
       <p:transition xmlns:p14="http://schemas.microsoft.com/office/powerpoint/2010/main" spd="slow" p14:dur="2000">
         <p159:morph option="byObject"/>
       </p:transition>
     </mc:Choice>
-    <mc:Fallback>
+    <mc:Fallback xmlns="">
       <p:transition spd="slow">
         <p:fade/>
       </p:transition>
@@ -8272,13 +8326,13 @@
   <p:clrMapOvr>
     <a:masterClrMapping/>
   </p:clrMapOvr>
-  <mc:AlternateContent xmlns:mc="http://schemas.openxmlformats.org/markup-compatibility/2006">
-    <mc:Choice xmlns:p159="http://schemas.microsoft.com/office/powerpoint/2015/09/main" Requires="p159">
+  <mc:AlternateContent xmlns:mc="http://schemas.openxmlformats.org/markup-compatibility/2006" xmlns:p159="http://schemas.microsoft.com/office/powerpoint/2015/09/main">
+    <mc:Choice Requires="p159">
       <p:transition xmlns:p14="http://schemas.microsoft.com/office/powerpoint/2010/main" spd="slow" p14:dur="2000">
         <p159:morph option="byObject"/>
       </p:transition>
     </mc:Choice>
-    <mc:Fallback>
+    <mc:Fallback xmlns="">
       <p:transition spd="slow">
         <p:fade/>
       </p:transition>
@@ -8525,13 +8579,13 @@
   <p:clrMapOvr>
     <a:masterClrMapping/>
   </p:clrMapOvr>
-  <mc:AlternateContent xmlns:mc="http://schemas.openxmlformats.org/markup-compatibility/2006">
-    <mc:Choice xmlns:p159="http://schemas.microsoft.com/office/powerpoint/2015/09/main" Requires="p159">
+  <mc:AlternateContent xmlns:mc="http://schemas.openxmlformats.org/markup-compatibility/2006" xmlns:p159="http://schemas.microsoft.com/office/powerpoint/2015/09/main">
+    <mc:Choice Requires="p159">
       <p:transition xmlns:p14="http://schemas.microsoft.com/office/powerpoint/2010/main" spd="slow" p14:dur="2000">
         <p159:morph option="byObject"/>
       </p:transition>
     </mc:Choice>
-    <mc:Fallback>
+    <mc:Fallback xmlns="">
       <p:transition spd="slow">
         <p:fade/>
       </p:transition>
@@ -9165,13 +9219,13 @@
   <p:clrMapOvr>
     <a:masterClrMapping/>
   </p:clrMapOvr>
-  <mc:AlternateContent xmlns:mc="http://schemas.openxmlformats.org/markup-compatibility/2006">
-    <mc:Choice xmlns:p159="http://schemas.microsoft.com/office/powerpoint/2015/09/main" Requires="p159">
+  <mc:AlternateContent xmlns:mc="http://schemas.openxmlformats.org/markup-compatibility/2006" xmlns:p159="http://schemas.microsoft.com/office/powerpoint/2015/09/main">
+    <mc:Choice Requires="p159">
       <p:transition xmlns:p14="http://schemas.microsoft.com/office/powerpoint/2010/main" spd="slow" p14:dur="2000">
         <p159:morph option="byObject"/>
       </p:transition>
     </mc:Choice>
-    <mc:Fallback>
+    <mc:Fallback xmlns="">
       <p:transition spd="slow">
         <p:fade/>
       </p:transition>
@@ -9957,13 +10011,13 @@
   <p:clrMapOvr>
     <a:masterClrMapping/>
   </p:clrMapOvr>
-  <mc:AlternateContent xmlns:mc="http://schemas.openxmlformats.org/markup-compatibility/2006">
-    <mc:Choice xmlns:p159="http://schemas.microsoft.com/office/powerpoint/2015/09/main" Requires="p159">
+  <mc:AlternateContent xmlns:mc="http://schemas.openxmlformats.org/markup-compatibility/2006" xmlns:p159="http://schemas.microsoft.com/office/powerpoint/2015/09/main">
+    <mc:Choice Requires="p159">
       <p:transition xmlns:p14="http://schemas.microsoft.com/office/powerpoint/2010/main" spd="slow" p14:dur="2000">
         <p159:morph option="byObject"/>
       </p:transition>
     </mc:Choice>
-    <mc:Fallback>
+    <mc:Fallback xmlns="">
       <p:transition spd="slow">
         <p:fade/>
       </p:transition>
@@ -10899,13 +10953,13 @@
   <p:clrMapOvr>
     <a:masterClrMapping/>
   </p:clrMapOvr>
-  <mc:AlternateContent xmlns:mc="http://schemas.openxmlformats.org/markup-compatibility/2006">
-    <mc:Choice xmlns:p159="http://schemas.microsoft.com/office/powerpoint/2015/09/main" Requires="p159">
+  <mc:AlternateContent xmlns:mc="http://schemas.openxmlformats.org/markup-compatibility/2006" xmlns:p159="http://schemas.microsoft.com/office/powerpoint/2015/09/main">
+    <mc:Choice Requires="p159">
       <p:transition xmlns:p14="http://schemas.microsoft.com/office/powerpoint/2010/main" spd="slow" p14:dur="2000">
         <p159:morph option="byObject"/>
       </p:transition>
     </mc:Choice>
-    <mc:Fallback>
+    <mc:Fallback xmlns="">
       <p:transition spd="slow">
         <p:fade/>
       </p:transition>
@@ -12381,13 +12435,13 @@
   <p:clrMapOvr>
     <a:masterClrMapping/>
   </p:clrMapOvr>
-  <mc:AlternateContent xmlns:mc="http://schemas.openxmlformats.org/markup-compatibility/2006">
-    <mc:Choice xmlns:p159="http://schemas.microsoft.com/office/powerpoint/2015/09/main" Requires="p159">
+  <mc:AlternateContent xmlns:mc="http://schemas.openxmlformats.org/markup-compatibility/2006" xmlns:p159="http://schemas.microsoft.com/office/powerpoint/2015/09/main">
+    <mc:Choice Requires="p159">
       <p:transition xmlns:p14="http://schemas.microsoft.com/office/powerpoint/2010/main" spd="slow" p14:dur="2000">
         <p159:morph option="byObject"/>
       </p:transition>
     </mc:Choice>
-    <mc:Fallback>
+    <mc:Fallback xmlns="">
       <p:transition spd="slow">
         <p:fade/>
       </p:transition>
@@ -13074,13 +13128,13 @@
   <p:clrMapOvr>
     <a:masterClrMapping/>
   </p:clrMapOvr>
-  <mc:AlternateContent xmlns:mc="http://schemas.openxmlformats.org/markup-compatibility/2006">
-    <mc:Choice xmlns:p159="http://schemas.microsoft.com/office/powerpoint/2015/09/main" Requires="p159">
+  <mc:AlternateContent xmlns:mc="http://schemas.openxmlformats.org/markup-compatibility/2006" xmlns:p159="http://schemas.microsoft.com/office/powerpoint/2015/09/main">
+    <mc:Choice Requires="p159">
       <p:transition xmlns:p14="http://schemas.microsoft.com/office/powerpoint/2010/main" spd="slow" p14:dur="2000">
         <p159:morph option="byObject"/>
       </p:transition>
     </mc:Choice>
-    <mc:Fallback>
+    <mc:Fallback xmlns="">
       <p:transition spd="slow">
         <p:fade/>
       </p:transition>

</xml_diff>